<commit_message>
3-minute pitch: 6-slide deck variant and script
</commit_message>
<xml_diff>
--- a/report/DecodeDetect_BatmanAndRobin.pptx
+++ b/report/DecodeDetect_BatmanAndRobin.pptx
@@ -115,35 +115,35 @@
   <p:extLst>
     <p:ext uri="{521415D9-36F7-43E2-AB2F-B90AF26B5E84}">
       <p14:sectionLst xmlns:p14="http://schemas.microsoft.com/office/powerpoint/2010/main">
-        <p14:section name="Opening" id="{164e68dd-224b-7385-7087-fbd9958d2a76}">
+        <p14:section name="Opening" id="{0d1b077f-c79e-0b7f-bcb3-f8960c26aeb1}">
           <p14:sldIdLst>
             <p14:sldId id="256"/>
           </p14:sldIdLst>
         </p14:section>
-        <p14:section name="Problem" id="{039d9d37-0e65-128c-c27e-3a06dde4f7d2}">
+        <p14:section name="Problem" id="{37e54a5e-7375-8dec-3bac-3ab80589b9cb}">
           <p14:sldIdLst>
             <p14:sldId id="257"/>
           </p14:sldIdLst>
         </p14:section>
-        <p14:section name="Insight" id="{d73d9421-72bd-35e3-201f-c944610026d9}">
+        <p14:section name="Insight" id="{7d28b2a7-0781-c126-38c5-c58e518eb466}">
           <p14:sldIdLst>
             <p14:sldId id="258"/>
           </p14:sldIdLst>
         </p14:section>
-        <p14:section name="Method" id="{41223e78-0a9a-e68c-8932-1c50dec729bf}">
+        <p14:section name="Method" id="{789bb5ff-a6f4-2f33-0301-288f77e85c43}">
           <p14:sldIdLst>
             <p14:sldId id="259"/>
             <p14:sldId id="260"/>
           </p14:sldIdLst>
         </p14:section>
-        <p14:section name="Results" id="{7f01ce23-9518-e353-b1e7-ee481c8f7895}">
+        <p14:section name="Results" id="{946edeae-971b-b034-43a5-93265885a8fa}">
           <p14:sldIdLst>
             <p14:sldId id="261"/>
             <p14:sldId id="262"/>
             <p14:sldId id="263"/>
           </p14:sldIdLst>
         </p14:section>
-        <p14:section name="Close" id="{8bd1504c-f686-9b36-993f-4f399f55c8f7}">
+        <p14:section name="Close" id="{4b97d7a6-7e10-27fe-515a-f4fce7d85f46}">
           <p14:sldIdLst>
             <p14:sldId id="264"/>
           </p14:sldIdLst>

</xml_diff>

<commit_message>
Slides and notes: relay cohort structure and raw-data review
</commit_message>
<xml_diff>
--- a/report/DecodeDetect_BatmanAndRobin.pptx
+++ b/report/DecodeDetect_BatmanAndRobin.pptx
@@ -115,35 +115,35 @@
   <p:extLst>
     <p:ext uri="{521415D9-36F7-43E2-AB2F-B90AF26B5E84}">
       <p14:sectionLst xmlns:p14="http://schemas.microsoft.com/office/powerpoint/2010/main">
-        <p14:section name="Opening" id="{0d1b077f-c79e-0b7f-bcb3-f8960c26aeb1}">
+        <p14:section name="Opening" id="{6117ea2f-861c-34ab-b14f-baed7d55ac5e}">
           <p14:sldIdLst>
             <p14:sldId id="256"/>
           </p14:sldIdLst>
         </p14:section>
-        <p14:section name="Problem" id="{37e54a5e-7375-8dec-3bac-3ab80589b9cb}">
+        <p14:section name="Problem" id="{6dfda750-df40-58f7-698e-7f3dbb1c3409}">
           <p14:sldIdLst>
             <p14:sldId id="257"/>
           </p14:sldIdLst>
         </p14:section>
-        <p14:section name="Insight" id="{7d28b2a7-0781-c126-38c5-c58e518eb466}">
+        <p14:section name="Insight" id="{3dec8f11-b207-5552-af9b-a19667e168f4}">
           <p14:sldIdLst>
             <p14:sldId id="258"/>
           </p14:sldIdLst>
         </p14:section>
-        <p14:section name="Method" id="{789bb5ff-a6f4-2f33-0301-288f77e85c43}">
+        <p14:section name="Method" id="{b466dd6b-a398-5db9-8b50-5bce6ef484fb}">
           <p14:sldIdLst>
             <p14:sldId id="259"/>
             <p14:sldId id="260"/>
           </p14:sldIdLst>
         </p14:section>
-        <p14:section name="Results" id="{946edeae-971b-b034-43a5-93265885a8fa}">
+        <p14:section name="Results" id="{21d0e495-da06-78d0-1412-5fcf537dec85}">
           <p14:sldIdLst>
             <p14:sldId id="261"/>
             <p14:sldId id="262"/>
             <p14:sldId id="263"/>
           </p14:sldIdLst>
         </p14:section>
-        <p14:section name="Close" id="{4b97d7a6-7e10-27fe-515a-f4fce7d85f46}">
+        <p14:section name="Close" id="{bccb5afd-9811-d3c9-533f-1ea552c6335a}">
           <p14:sldIdLst>
             <p14:sldId id="264"/>
           </p14:sldIdLst>
@@ -6408,7 +6408,7 @@
                   <a:schemeClr val="tx2"/>
                 </a:solidFill>
               </a:rPr>
-              <a:t>Hard relay cases (16% of suspicious) are built from the same template as 19,800 normal ones; about 20 signals we tried stayed at chance. 25 labels are random by design.</a:t>
+              <a:t>Hard relay cases (16% of suspicious) come in 12 batches of 100 near-identical relay scenarios with exactly one laundering per batch; even against its 99 siblings it looks ordinary on every stat we tried. 25 labels are random by design.</a:t>
             </a:r>
             <a:endParaRPr lang="en-US" sz="1600" dirty="0"/>
           </a:p>

</xml_diff>

<commit_message>
Final check: run.py at e896834 reproduces a valid file in 22 min; example ranks from the final file
</commit_message>
<xml_diff>
--- a/report/DecodeDetect_BatmanAndRobin.pptx
+++ b/report/DecodeDetect_BatmanAndRobin.pptx
@@ -115,35 +115,35 @@
   <p:extLst>
     <p:ext uri="{521415D9-36F7-43E2-AB2F-B90AF26B5E84}">
       <p14:sectionLst xmlns:p14="http://schemas.microsoft.com/office/powerpoint/2010/main">
-        <p14:section name="Opening" id="{6117ea2f-861c-34ab-b14f-baed7d55ac5e}">
+        <p14:section name="Opening" id="{cf9fcc31-f213-bbbc-a521-4e80d4a7a691}">
           <p14:sldIdLst>
             <p14:sldId id="256"/>
           </p14:sldIdLst>
         </p14:section>
-        <p14:section name="Problem" id="{6dfda750-df40-58f7-698e-7f3dbb1c3409}">
+        <p14:section name="Problem" id="{cbfbfc46-81a7-e611-a92a-9a717241569d}">
           <p14:sldIdLst>
             <p14:sldId id="257"/>
           </p14:sldIdLst>
         </p14:section>
-        <p14:section name="Insight" id="{3dec8f11-b207-5552-af9b-a19667e168f4}">
+        <p14:section name="Insight" id="{1b423c61-456f-3189-6194-0a9cd2b39edb}">
           <p14:sldIdLst>
             <p14:sldId id="258"/>
           </p14:sldIdLst>
         </p14:section>
-        <p14:section name="Method" id="{b466dd6b-a398-5db9-8b50-5bce6ef484fb}">
+        <p14:section name="Method" id="{2d3c3bf0-7944-f17d-99a1-b9a2f457a08a}">
           <p14:sldIdLst>
             <p14:sldId id="259"/>
             <p14:sldId id="260"/>
           </p14:sldIdLst>
         </p14:section>
-        <p14:section name="Results" id="{21d0e495-da06-78d0-1412-5fcf537dec85}">
+        <p14:section name="Results" id="{a4891f71-4ca5-58e6-02f2-1f8d03728482}">
           <p14:sldIdLst>
             <p14:sldId id="261"/>
             <p14:sldId id="262"/>
             <p14:sldId id="263"/>
           </p14:sldIdLst>
         </p14:section>
-        <p14:section name="Close" id="{bccb5afd-9811-d3c9-533f-1ea552c6335a}">
+        <p14:section name="Close" id="{3939a738-c4e1-1639-8bcf-91b789d1e51d}">
           <p14:sldIdLst>
             <p14:sldId id="264"/>
           </p14:sldIdLst>
@@ -5506,7 +5506,7 @@
       </p:sp>
       <p:sp>
         <p:nvSpPr>
-          <p:cNvPr id="24" name="card Rank 4   8AA1DCA1..."/>
+          <p:cNvPr id="24" name="card Rank 16   8AA1DCA1..."/>
           <p:cNvSpPr/>
           <p:nvPr/>
         </p:nvSpPr>
@@ -5564,7 +5564,7 @@
                   <a:schemeClr val="tx1"/>
                 </a:solidFill>
               </a:rPr>
-              <a:t>Rank 4   8AA1DCA1...</a:t>
+              <a:t>Rank 16   8AA1DCA1...</a:t>
             </a:r>
             <a:endParaRPr lang="en-US" sz="1600" dirty="0"/>
           </a:p>
@@ -5589,7 +5589,7 @@
       </p:sp>
       <p:sp>
         <p:nvSpPr>
-          <p:cNvPr id="26" name="card Rank 5   41EF2ECA..."/>
+          <p:cNvPr id="26" name="card Rank 93   41EF2ECA..."/>
           <p:cNvSpPr/>
           <p:nvPr/>
         </p:nvSpPr>
@@ -5647,7 +5647,7 @@
                   <a:schemeClr val="tx1"/>
                 </a:solidFill>
               </a:rPr>
-              <a:t>Rank 5   41EF2ECA...</a:t>
+              <a:t>Rank 93   41EF2ECA...</a:t>
             </a:r>
             <a:endParaRPr lang="en-US" sz="1600" dirty="0"/>
           </a:p>
@@ -5664,7 +5664,7 @@
                   <a:schemeClr val="tx2"/>
                 </a:solidFill>
               </a:rPr>
-              <a:t>Four new wallets, four assets, merged in GBP in 2 minutes. The collector's next payment, to an old contact, ranks 17,189: we score the motif, not the wallet.</a:t>
+              <a:t>Four new wallets, four assets, merged in GBP in 2 minutes. The collector's next payment, to an old contact, ranks 36060: we score the motif, not the wallet.</a:t>
             </a:r>
             <a:endParaRPr lang="en-US" sz="1600" dirty="0"/>
           </a:p>
@@ -6072,7 +6072,7 @@
                 <a:ea typeface="Cambria" pitchFamily="34" charset="-122"/>
                 <a:cs typeface="Cambria" pitchFamily="34" charset="-120"/>
               </a:rPr>
-              <a:t>1,975</a:t>
+              <a:t>1,204</a:t>
             </a:r>
             <a:endParaRPr lang="en-US" sz="4000" dirty="0"/>
           </a:p>

</xml_diff>

<commit_message>
Final numbers: 70.3 six-model blend, reproduced from scratch; decks updated
</commit_message>
<xml_diff>
--- a/report/DecodeDetect_BatmanAndRobin.pptx
+++ b/report/DecodeDetect_BatmanAndRobin.pptx
@@ -115,35 +115,35 @@
   <p:extLst>
     <p:ext uri="{521415D9-36F7-43E2-AB2F-B90AF26B5E84}">
       <p14:sectionLst xmlns:p14="http://schemas.microsoft.com/office/powerpoint/2010/main">
-        <p14:section name="Opening" id="{cf9fcc31-f213-bbbc-a521-4e80d4a7a691}">
+        <p14:section name="Opening" id="{a2803ba1-30ee-c2ec-92b2-fb4c4b809392}">
           <p14:sldIdLst>
             <p14:sldId id="256"/>
           </p14:sldIdLst>
         </p14:section>
-        <p14:section name="Problem" id="{cbfbfc46-81a7-e611-a92a-9a717241569d}">
+        <p14:section name="Problem" id="{3e8c44fa-6a39-39d9-c054-6aa2c71ac623}">
           <p14:sldIdLst>
             <p14:sldId id="257"/>
           </p14:sldIdLst>
         </p14:section>
-        <p14:section name="Insight" id="{1b423c61-456f-3189-6194-0a9cd2b39edb}">
+        <p14:section name="Insight" id="{f99e4cea-94b7-78b9-a639-571a4839f6e7}">
           <p14:sldIdLst>
             <p14:sldId id="258"/>
           </p14:sldIdLst>
         </p14:section>
-        <p14:section name="Method" id="{2d3c3bf0-7944-f17d-99a1-b9a2f457a08a}">
+        <p14:section name="Method" id="{f6cd8a4e-2dbe-de65-7c31-d1307006829d}">
           <p14:sldIdLst>
             <p14:sldId id="259"/>
             <p14:sldId id="260"/>
           </p14:sldIdLst>
         </p14:section>
-        <p14:section name="Results" id="{a4891f71-4ca5-58e6-02f2-1f8d03728482}">
+        <p14:section name="Results" id="{bad89b64-10f8-b7d7-483d-e0b84500618c}">
           <p14:sldIdLst>
             <p14:sldId id="261"/>
             <p14:sldId id="262"/>
             <p14:sldId id="263"/>
           </p14:sldIdLst>
         </p14:section>
-        <p14:section name="Close" id="{3939a738-c4e1-1639-8bcf-91b789d1e51d}">
+        <p14:section name="Close" id="{48567ddd-7110-5455-3dca-ad8450234f4a}">
           <p14:sldIdLst>
             <p14:sldId id="264"/>
           </p14:sldIdLst>
@@ -4717,7 +4717,7 @@
                 <a:ea typeface="Cambria" pitchFamily="34" charset="-122"/>
                 <a:cs typeface="Cambria" pitchFamily="34" charset="-120"/>
               </a:rPr>
-              <a:t>69.2</a:t>
+              <a:t>70.3</a:t>
             </a:r>
             <a:endParaRPr lang="en-US" sz="4000" dirty="0"/>
           </a:p>
@@ -4753,7 +4753,7 @@
                   <a:schemeClr val="tx2"/>
                 </a:solidFill>
               </a:rPr>
-              <a:t>final leaderboard score (v17, best so far)</a:t>
+              <a:t>final leaderboard score (blend of six models)</a:t>
             </a:r>
             <a:endParaRPr lang="en-US" sz="1300" dirty="0"/>
           </a:p>
@@ -4828,7 +4828,7 @@
                   <a:schemeClr val="tx2"/>
                 </a:solidFill>
               </a:rPr>
-              <a:t>out-of-fold AP, grouped 5-fold</a:t>
+              <a:t>out-of-fold AP of v17, the strongest single model</a:t>
             </a:r>
             <a:endParaRPr lang="en-US" sz="1300" dirty="0"/>
           </a:p>

</xml_diff>